<commit_message>
docs: update MCP analysis to reflect 34-tool HTTP catalog (admin tools migrated to REST)
</commit_message>
<xml_diff>
--- a/handovers/Launch-Jobs_panels2/giljoai workflow.pptx
+++ b/handovers/Launch-Jobs_panels2/giljoai workflow.pptx
@@ -234,7 +234,7 @@
           <a:p>
             <a:fld id="{416C67DE-CFD7-4293-887A-6877041E4FFC}" type="datetimeFigureOut">
               <a:rPr lang="en-US" smtClean="0"/>
-              <a:t>11/16/2025</a:t>
+              <a:t>11/18/2025</a:t>
             </a:fld>
             <a:endParaRPr lang="en-US"/>
           </a:p>
@@ -648,7 +648,7 @@
           <a:p>
             <a:fld id="{ED9B7CB9-CB20-4E51-B0CA-42467449EB46}" type="datetime1">
               <a:rPr lang="en-US" smtClean="0"/>
-              <a:t>11/16/2025</a:t>
+              <a:t>11/18/2025</a:t>
             </a:fld>
             <a:endParaRPr lang="en-US"/>
           </a:p>
@@ -846,7 +846,7 @@
           <a:p>
             <a:fld id="{8CC60638-A82E-46CE-BC0C-48D35FB3C658}" type="datetime1">
               <a:rPr lang="en-US" smtClean="0"/>
-              <a:t>11/16/2025</a:t>
+              <a:t>11/18/2025</a:t>
             </a:fld>
             <a:endParaRPr lang="en-US"/>
           </a:p>
@@ -1054,7 +1054,7 @@
           <a:p>
             <a:fld id="{B6029D30-CC6F-48F3-8489-7CBFA664EED5}" type="datetime1">
               <a:rPr lang="en-US" smtClean="0"/>
-              <a:t>11/16/2025</a:t>
+              <a:t>11/18/2025</a:t>
             </a:fld>
             <a:endParaRPr lang="en-US"/>
           </a:p>
@@ -1252,7 +1252,7 @@
           <a:p>
             <a:fld id="{6C9E7DF4-3877-4BFE-B5C4-861B9A235AD6}" type="datetime1">
               <a:rPr lang="en-US" smtClean="0"/>
-              <a:t>11/16/2025</a:t>
+              <a:t>11/18/2025</a:t>
             </a:fld>
             <a:endParaRPr lang="en-US"/>
           </a:p>
@@ -1537,7 +1537,7 @@
           <a:p>
             <a:fld id="{FE5AE3B2-C9E6-4BBD-A24E-B1D23E88ACAD}" type="datetime1">
               <a:rPr lang="en-US" smtClean="0"/>
-              <a:t>11/16/2025</a:t>
+              <a:t>11/18/2025</a:t>
             </a:fld>
             <a:endParaRPr lang="en-US"/>
           </a:p>
@@ -1802,7 +1802,7 @@
           <a:p>
             <a:fld id="{5980A91E-44C5-48EF-AB9E-C9EE62A71141}" type="datetime1">
               <a:rPr lang="en-US" smtClean="0"/>
-              <a:t>11/16/2025</a:t>
+              <a:t>11/18/2025</a:t>
             </a:fld>
             <a:endParaRPr lang="en-US"/>
           </a:p>
@@ -2214,7 +2214,7 @@
           <a:p>
             <a:fld id="{B2530319-9480-423F-A385-59E530B00954}" type="datetime1">
               <a:rPr lang="en-US" smtClean="0"/>
-              <a:t>11/16/2025</a:t>
+              <a:t>11/18/2025</a:t>
             </a:fld>
             <a:endParaRPr lang="en-US"/>
           </a:p>
@@ -2355,7 +2355,7 @@
           <a:p>
             <a:fld id="{A2362125-4BC4-4B6E-951B-5A8C76AD041F}" type="datetime1">
               <a:rPr lang="en-US" smtClean="0"/>
-              <a:t>11/16/2025</a:t>
+              <a:t>11/18/2025</a:t>
             </a:fld>
             <a:endParaRPr lang="en-US"/>
           </a:p>
@@ -2468,7 +2468,7 @@
           <a:p>
             <a:fld id="{540900B7-0B4F-478F-94C9-ACD28367F078}" type="datetime1">
               <a:rPr lang="en-US" smtClean="0"/>
-              <a:t>11/16/2025</a:t>
+              <a:t>11/18/2025</a:t>
             </a:fld>
             <a:endParaRPr lang="en-US"/>
           </a:p>
@@ -2779,7 +2779,7 @@
           <a:p>
             <a:fld id="{8688C4A6-149A-4F56-BCC7-939EECDCA4D5}" type="datetime1">
               <a:rPr lang="en-US" smtClean="0"/>
-              <a:t>11/16/2025</a:t>
+              <a:t>11/18/2025</a:t>
             </a:fld>
             <a:endParaRPr lang="en-US"/>
           </a:p>
@@ -3067,7 +3067,7 @@
           <a:p>
             <a:fld id="{04FA1CE9-15F9-4F43-A295-F3BC07C72081}" type="datetime1">
               <a:rPr lang="en-US" smtClean="0"/>
-              <a:t>11/16/2025</a:t>
+              <a:t>11/18/2025</a:t>
             </a:fld>
             <a:endParaRPr lang="en-US"/>
           </a:p>
@@ -3308,7 +3308,7 @@
           <a:p>
             <a:fld id="{BA3D8D1C-4A3B-4F03-A778-92E4AFA91CAB}" type="datetime1">
               <a:rPr lang="en-US" smtClean="0"/>
-              <a:t>11/16/2025</a:t>
+              <a:t>11/18/2025</a:t>
             </a:fld>
             <a:endParaRPr lang="en-US"/>
           </a:p>

</xml_diff>